<commit_message>
feat(lec23): instruction timing done, finally
</commit_message>
<xml_diff>
--- a/content/datapath/pptx/datapath-addi.pptx
+++ b/content/datapath/pptx/datapath-addi.pptx
@@ -204,7 +204,7 @@
           <a:p>
             <a:fld id="{E9179AFB-556A-7647-8681-E8CCC214AEB4}" type="datetimeFigureOut">
               <a:rPr lang="en-US" smtClean="0"/>
-              <a:t>3/11/26</a:t>
+              <a:t>3/25/26</a:t>
             </a:fld>
             <a:endParaRPr lang="en-US"/>
           </a:p>
@@ -28284,6 +28284,74 @@
           </p:cxnSp>
         </p:grpSp>
       </p:grpSp>
+      <p:sp>
+        <p:nvSpPr>
+          <p:cNvPr id="4" name="TextBox 3">
+            <a:extLst>
+              <a:ext uri="{FF2B5EF4-FFF2-40B4-BE49-F238E27FC236}">
+                <a16:creationId xmlns:a16="http://schemas.microsoft.com/office/drawing/2014/main" id="{78ABAD82-F024-70F0-D624-B0BEC12BB18E}"/>
+              </a:ext>
+            </a:extLst>
+          </p:cNvPr>
+          <p:cNvSpPr txBox="1"/>
+          <p:nvPr/>
+        </p:nvSpPr>
+        <p:spPr>
+          <a:xfrm>
+            <a:off x="4062897" y="5552119"/>
+            <a:ext cx="817853" cy="520142"/>
+          </a:xfrm>
+          <a:prstGeom prst="rect">
+            <a:avLst/>
+          </a:prstGeom>
+          <a:noFill/>
+        </p:spPr>
+        <p:txBody>
+          <a:bodyPr wrap="none" rtlCol="0">
+            <a:spAutoFit/>
+          </a:bodyPr>
+          <a:lstStyle/>
+          <a:p>
+            <a:pPr algn="ctr">
+              <a:lnSpc>
+                <a:spcPct val="85000"/>
+              </a:lnSpc>
+            </a:pPr>
+            <a:r>
+              <a:rPr lang="en-US" sz="1600" dirty="0" err="1">
+                <a:solidFill>
+                  <a:schemeClr val="accent3"/>
+                </a:solidFill>
+                <a:latin typeface="18 VAG Rounded Light   02390" pitchFamily="2" charset="0"/>
+              </a:rPr>
+              <a:t>ImmSel</a:t>
+            </a:r>
+            <a:endParaRPr lang="en-US" sz="1600" dirty="0">
+              <a:solidFill>
+                <a:schemeClr val="accent3"/>
+              </a:solidFill>
+              <a:latin typeface="18 VAG Rounded Light   02390" pitchFamily="2" charset="0"/>
+            </a:endParaRPr>
+          </a:p>
+          <a:p>
+            <a:pPr algn="ctr">
+              <a:lnSpc>
+                <a:spcPct val="85000"/>
+              </a:lnSpc>
+            </a:pPr>
+            <a:r>
+              <a:rPr lang="en-US" sz="1600" b="1" dirty="0">
+                <a:solidFill>
+                  <a:schemeClr val="accent5"/>
+                </a:solidFill>
+                <a:latin typeface="Courier New" panose="02070309020205020404" pitchFamily="49" charset="0"/>
+                <a:cs typeface="Courier New" panose="02070309020205020404" pitchFamily="49" charset="0"/>
+              </a:rPr>
+              <a:t>I</a:t>
+            </a:r>
+          </a:p>
+        </p:txBody>
+      </p:sp>
     </p:spTree>
     <p:extLst>
       <p:ext uri="{BB962C8B-B14F-4D97-AF65-F5344CB8AC3E}">

</xml_diff>

<commit_message>
feat(lec23): instruction timing (#66)
Co-authored-by: Cassie Jeng <59851290+cjeng8771@users.noreply.github.com>
Co-authored-by: Flying010 <snehamuppalla@gmail.com>
</commit_message>
<xml_diff>
--- a/content/datapath/pptx/datapath-addi.pptx
+++ b/content/datapath/pptx/datapath-addi.pptx
@@ -204,7 +204,7 @@
           <a:p>
             <a:fld id="{E9179AFB-556A-7647-8681-E8CCC214AEB4}" type="datetimeFigureOut">
               <a:rPr lang="en-US" smtClean="0"/>
-              <a:t>3/11/26</a:t>
+              <a:t>3/25/26</a:t>
             </a:fld>
             <a:endParaRPr lang="en-US"/>
           </a:p>
@@ -28284,6 +28284,74 @@
           </p:cxnSp>
         </p:grpSp>
       </p:grpSp>
+      <p:sp>
+        <p:nvSpPr>
+          <p:cNvPr id="4" name="TextBox 3">
+            <a:extLst>
+              <a:ext uri="{FF2B5EF4-FFF2-40B4-BE49-F238E27FC236}">
+                <a16:creationId xmlns:a16="http://schemas.microsoft.com/office/drawing/2014/main" id="{78ABAD82-F024-70F0-D624-B0BEC12BB18E}"/>
+              </a:ext>
+            </a:extLst>
+          </p:cNvPr>
+          <p:cNvSpPr txBox="1"/>
+          <p:nvPr/>
+        </p:nvSpPr>
+        <p:spPr>
+          <a:xfrm>
+            <a:off x="4062897" y="5552119"/>
+            <a:ext cx="817853" cy="520142"/>
+          </a:xfrm>
+          <a:prstGeom prst="rect">
+            <a:avLst/>
+          </a:prstGeom>
+          <a:noFill/>
+        </p:spPr>
+        <p:txBody>
+          <a:bodyPr wrap="none" rtlCol="0">
+            <a:spAutoFit/>
+          </a:bodyPr>
+          <a:lstStyle/>
+          <a:p>
+            <a:pPr algn="ctr">
+              <a:lnSpc>
+                <a:spcPct val="85000"/>
+              </a:lnSpc>
+            </a:pPr>
+            <a:r>
+              <a:rPr lang="en-US" sz="1600" dirty="0" err="1">
+                <a:solidFill>
+                  <a:schemeClr val="accent3"/>
+                </a:solidFill>
+                <a:latin typeface="18 VAG Rounded Light   02390" pitchFamily="2" charset="0"/>
+              </a:rPr>
+              <a:t>ImmSel</a:t>
+            </a:r>
+            <a:endParaRPr lang="en-US" sz="1600" dirty="0">
+              <a:solidFill>
+                <a:schemeClr val="accent3"/>
+              </a:solidFill>
+              <a:latin typeface="18 VAG Rounded Light   02390" pitchFamily="2" charset="0"/>
+            </a:endParaRPr>
+          </a:p>
+          <a:p>
+            <a:pPr algn="ctr">
+              <a:lnSpc>
+                <a:spcPct val="85000"/>
+              </a:lnSpc>
+            </a:pPr>
+            <a:r>
+              <a:rPr lang="en-US" sz="1600" b="1" dirty="0">
+                <a:solidFill>
+                  <a:schemeClr val="accent5"/>
+                </a:solidFill>
+                <a:latin typeface="Courier New" panose="02070309020205020404" pitchFamily="49" charset="0"/>
+                <a:cs typeface="Courier New" panose="02070309020205020404" pitchFamily="49" charset="0"/>
+              </a:rPr>
+              <a:t>I</a:t>
+            </a:r>
+          </a:p>
+        </p:txBody>
+      </p:sp>
     </p:spTree>
     <p:extLst>
       <p:ext uri="{BB962C8B-B14F-4D97-AF65-F5344CB8AC3E}">

</xml_diff>